<commit_message>
Tighten pitch deck copy for clarity and credibility
Rewrite the slide 1-3 narrative in active voice with concrete subjects
(QA manager, the agent), drop em dashes and the "complaint becomes a
stop-ship" phrasing, and fix "minutes, not days". Keep the evidence
intact: 37/37 read-back, ~$360,480 across 3 zones, 11 excluded with a
reason each. Regenerated PDF + PPTX on the official template.

Co-authored-by: Cursor <cursoragent@cursor.com>
</commit_message>
<xml_diff>
--- a/docs/red-batch-deck.pptx
+++ b/docs/red-batch-deck.pptx
@@ -25134,7 +25134,7 @@
                   <a:srgbClr val="0D1117"/>
                 </a:solidFill>
               </a:rPr>
-              <a:t>A product-safety complaint becomes a human-approved stop-ship on the exact right orders — a governed UiPath Maestro Case agent with a saved, reopenable record.</a:t>
+              <a:t>A safety complaint arrives. A QA manager approves once, and the agent holds only the right orders. Red Batch runs as a governed UiPath Maestro Case agent that saves a record you can reopen.</a:t>
             </a:r>
             <a:endParaRPr sz="1800">
               <a:solidFill>
@@ -25521,7 +25521,7 @@
                   <a:srgbClr val="FFFFFF"/>
                 </a:highlight>
               </a:rPr>
-              <a:t>When a safety complaint lands on a lot you might still be shipping, you have minutes, not days. Teams either freeze the whole warehouse — and break shipping for everyone — or chase orders by hand in a spreadsheet while defective units keep going out. There is no fast, governed way to hold exactly the right orders, behind a human sign-off, with proof of what changed.</a:t>
+              <a:t>A safety complaint lands on a lot you may still be shipping, and you have minutes to act. Both usual options are bad: freeze the whole warehouse and you break shipping for everyone, or chase the affected orders by hand in a spreadsheet while defective units keep going out. Neither one holds the right orders behind a human sign-off, and neither leaves proof of what changed.</a:t>
             </a:r>
             <a:endParaRPr/>
           </a:p>
@@ -25652,7 +25652,7 @@
                   <a:srgbClr val="FFFFFF"/>
                 </a:highlight>
               </a:rPr>
-              <a:t>Red Batch is a governed containment workspace. The Batch Containment Agent traces the bad lot to its SKU and warehouse and fans out to every Ready-to-Ship order in scope (37 to hold, 11 excluded with a reason each). Nothing changes until a QA manager approves — a real UiPath Action Center task. On approval it quarantines those orders (≈$360,480 across 3 zones), verifies by reading back (37/37), and saves a reopenable Stop-Ship Packet. Low-confidence signals route to human review.</a:t>
+              <a:t>Red Batch is a governed containment workspace. The Batch Containment Agent maps the bad lot to its SKU and warehouse, then fans out across every Ready-to-Ship order in scope: 37 to hold, 11 excluded with a reason each. Nothing moves until a QA manager approves the hold in a real UiPath Action Center task. On sign-off, the agent quarantines those orders (about $360,480 across 3 zones), reads the state back to confirm every one (37/37), and saves a reopenable Stop-Ship Packet. When unsure, it asks a person.</a:t>
             </a:r>
             <a:endParaRPr>
               <a:solidFill>
@@ -26968,7 +26968,7 @@
                   <a:srgbClr val="FFFFFF"/>
                 </a:highlight>
               </a:rPr>
-              <a:t>Holds exactly the right orders — 37 held, 11 excluded with a reason each — instead of freezing the whole warehouse.</a:t>
+              <a:t>Holds the right orders, not the whole warehouse: 37 held, 11 excluded with a reason each.</a:t>
             </a:r>
             <a:endParaRPr sz="1800">
               <a:solidFill>
@@ -27005,7 +27005,7 @@
                   <a:srgbClr val="FFFFFF"/>
                 </a:highlight>
               </a:rPr>
-              <a:t>Every state change is gated by a real human approval — a live UiPath Action Center task — before anything moves.</a:t>
+              <a:t>A real person signs off in a live UiPath Action Center task before any state changes.</a:t>
             </a:r>
             <a:endParaRPr sz="1800">
               <a:solidFill>
@@ -27042,7 +27042,7 @@
                   <a:srgbClr val="FFFFFF"/>
                 </a:highlight>
               </a:rPr>
-              <a:t>Verifiable outcome: a saved, reopenable Stop-Ship Packet with the before/after diff, evidence, named approver, and exclusions.</a:t>
+              <a:t>Every run ends in a reopenable Stop-Ship Packet: before and after state, evidence, the approver's name, and the exclusions.</a:t>
             </a:r>
             <a:endParaRPr sz="1800">
               <a:solidFill>
@@ -27079,7 +27079,7 @@
                   <a:srgbClr val="FFFFFF"/>
                 </a:highlight>
               </a:rPr>
-              <a:t>Honest, auditable automation: low-confidence cases route to human review; each step writes a governed run.</a:t>
+              <a:t>When the agent is not confident, a person reviews the case. Every step writes a governed run you can audit.</a:t>
             </a:r>
             <a:endParaRPr sz="1800">
               <a:solidFill>

</xml_diff>

<commit_message>
Deploy the coded agent as a Process and surface it in deck + docs
Create a Release from the published package so it also appears under Shared ->
Automations -> Processes ("Red Batch Containment Agent", Function (python),
v1.0.0, entry point main). Add the Process screenshot to README and
docs/uipath-proof.md, and place both the Packages and Processes screenshots on
the deck's Solution architecture slide so the live UiPath usage is shown visually.

Co-authored-by: Cursor <cursoragent@cursor.com>
</commit_message>
<xml_diff>
--- a/docs/red-batch-deck.pptx
+++ b/docs/red-batch-deck.pptx
@@ -27460,6 +27460,98 @@
           </a:p>
         </p:txBody>
       </p:sp>
+      <p:sp>
+        <p:nvSpPr>
+          <p:cNvPr id="200" name="TextBox 199"/>
+          <p:cNvSpPr txBox="1"/>
+          <p:nvPr/>
+        </p:nvSpPr>
+        <p:spPr>
+          <a:xfrm>
+            <a:off x="329184" y="3968496"/>
+            <a:ext cx="11521440" cy="274320"/>
+          </a:xfrm>
+          <a:prstGeom prst="rect">
+            <a:avLst/>
+          </a:prstGeom>
+          <a:noFill/>
+        </p:spPr>
+        <p:txBody>
+          <a:bodyPr wrap="square">
+            <a:spAutoFit/>
+          </a:bodyPr>
+          <a:lstStyle/>
+          <a:p>
+            <a:pPr algn="ctr"/>
+            <a:r>
+              <a:rPr sz="1200" b="1">
+                <a:solidFill>
+                  <a:srgbClr val="1D1D1F"/>
+                </a:solidFill>
+              </a:rPr>
+              <a:t>Live in the UiPath tenant — coded agent published (Tenant → Packages, left) and deployed as a Process (Shared → Processes, right)</a:t>
+            </a:r>
+          </a:p>
+        </p:txBody>
+      </p:sp>
+      <p:pic>
+        <p:nvPicPr>
+          <p:cNvPr id="201" name="Picture 200" descr="uipath-orchestrator-package.png"/>
+          <p:cNvPicPr>
+            <a:picLocks noChangeAspect="1"/>
+          </p:cNvPicPr>
+          <p:nvPr/>
+        </p:nvPicPr>
+        <p:blipFill>
+          <a:blip r:embed="rId3"/>
+          <a:stretch>
+            <a:fillRect/>
+          </a:stretch>
+        </p:blipFill>
+        <p:spPr>
+          <a:xfrm>
+            <a:off x="1371600" y="4261104"/>
+            <a:ext cx="4389120" cy="2377690"/>
+          </a:xfrm>
+          <a:prstGeom prst="rect">
+            <a:avLst/>
+          </a:prstGeom>
+          <a:ln w="9525">
+            <a:solidFill>
+              <a:srgbClr val="C8CCD0"/>
+            </a:solidFill>
+          </a:ln>
+        </p:spPr>
+      </p:pic>
+      <p:pic>
+        <p:nvPicPr>
+          <p:cNvPr id="202" name="Picture 201" descr="uipath-orchestrator-process.png"/>
+          <p:cNvPicPr>
+            <a:picLocks noChangeAspect="1"/>
+          </p:cNvPicPr>
+          <p:nvPr/>
+        </p:nvPicPr>
+        <p:blipFill>
+          <a:blip r:embed="rId4"/>
+          <a:stretch>
+            <a:fillRect/>
+          </a:stretch>
+        </p:blipFill>
+        <p:spPr>
+          <a:xfrm>
+            <a:off x="6419088" y="4261104"/>
+            <a:ext cx="4389120" cy="2377690"/>
+          </a:xfrm>
+          <a:prstGeom prst="rect">
+            <a:avLst/>
+          </a:prstGeom>
+          <a:ln w="9525">
+            <a:solidFill>
+              <a:srgbClr val="C8CCD0"/>
+            </a:solidFill>
+          </a:ln>
+        </p:spPr>
+      </p:pic>
     </p:spTree>
   </p:cSld>
   <p:clrMapOvr>

</xml_diff>